<commit_message>
update topic 7 slide decks
</commit_message>
<xml_diff>
--- a/topic07-TDD-and-JUnit/unit-07a-lectures/talk-2-junit-product-class/b-prog-fund-2-junit-producttest.pptx
+++ b/topic07-TDD-and-JUnit/unit-07a-lectures/talk-2-junit-product-class/b-prog-fund-2-junit-producttest.pptx
@@ -253,7 +253,7 @@
           <a:p>
             <a:fld id="{56BC3C30-7F3D-4B20-9974-47C57B22CA6E}" type="datetimeFigureOut">
               <a:rPr lang="en-IE" smtClean="0"/>
-              <a:t>03/03/2026</a:t>
+              <a:t>07/03/2026</a:t>
             </a:fld>
             <a:endParaRPr lang="en-IE"/>
           </a:p>
@@ -1408,7 +1408,7 @@
             <a:fld id="{1D8BD707-D9CF-40AE-B4C6-C98DA3205C09}" type="datetimeFigureOut">
               <a:rPr lang="en-US" smtClean="0"/>
               <a:pPr/>
-              <a:t>3/3/2026</a:t>
+              <a:t>3/7/26</a:t>
             </a:fld>
             <a:endParaRPr lang="en-US"/>
           </a:p>
@@ -1573,7 +1573,7 @@
             <a:fld id="{1D8BD707-D9CF-40AE-B4C6-C98DA3205C09}" type="datetimeFigureOut">
               <a:rPr lang="en-US" smtClean="0"/>
               <a:pPr/>
-              <a:t>3/3/2026</a:t>
+              <a:t>3/7/26</a:t>
             </a:fld>
             <a:endParaRPr lang="en-US"/>
           </a:p>
@@ -1748,7 +1748,7 @@
             <a:fld id="{1D8BD707-D9CF-40AE-B4C6-C98DA3205C09}" type="datetimeFigureOut">
               <a:rPr lang="en-US" smtClean="0"/>
               <a:pPr/>
-              <a:t>3/3/2026</a:t>
+              <a:t>3/7/26</a:t>
             </a:fld>
             <a:endParaRPr lang="en-US"/>
           </a:p>
@@ -1924,7 +1924,7 @@
           </a:ln>
           <a:extLst>
             <a:ext uri="{C572A759-6A51-4108-AA02-DFA0A04FC94B}">
-              <ma14:wrappingTextBoxFlag xmlns:ma14="http://schemas.microsoft.com/office/mac/drawingml/2011/main" xmlns="" val="1"/>
+              <ma14:wrappingTextBoxFlag xmlns="" xmlns:ma14="http://schemas.microsoft.com/office/mac/drawingml/2011/main" val="1"/>
             </a:ext>
           </a:extLst>
         </p:spPr>
@@ -2011,7 +2011,7 @@
             <a:effectLst/>
             <a:extLst>
               <a:ext uri="{C572A759-6A51-4108-AA02-DFA0A04FC94B}">
-                <ma14:wrappingTextBoxFlag xmlns:ma14="http://schemas.microsoft.com/office/mac/drawingml/2011/main" xmlns="" val="1"/>
+                <ma14:wrappingTextBoxFlag xmlns="" xmlns:ma14="http://schemas.microsoft.com/office/mac/drawingml/2011/main" val="1"/>
               </a:ext>
             </a:extLst>
           </p:spPr>
@@ -2084,7 +2084,7 @@
             <a:effectLst/>
             <a:extLst>
               <a:ext uri="{C572A759-6A51-4108-AA02-DFA0A04FC94B}">
-                <ma14:wrappingTextBoxFlag xmlns:ma14="http://schemas.microsoft.com/office/mac/drawingml/2011/main" xmlns="" val="1"/>
+                <ma14:wrappingTextBoxFlag xmlns="" xmlns:ma14="http://schemas.microsoft.com/office/mac/drawingml/2011/main" val="1"/>
               </a:ext>
             </a:extLst>
           </p:spPr>
@@ -2135,7 +2135,7 @@
             <a:effectLst/>
             <a:extLst>
               <a:ext uri="{C572A759-6A51-4108-AA02-DFA0A04FC94B}">
-                <ma14:wrappingTextBoxFlag xmlns:ma14="http://schemas.microsoft.com/office/mac/drawingml/2011/main" xmlns="" val="1"/>
+                <ma14:wrappingTextBoxFlag xmlns="" xmlns:ma14="http://schemas.microsoft.com/office/mac/drawingml/2011/main" val="1"/>
               </a:ext>
             </a:extLst>
           </p:spPr>
@@ -2528,7 +2528,7 @@
             <a:fld id="{1D8BD707-D9CF-40AE-B4C6-C98DA3205C09}" type="datetimeFigureOut">
               <a:rPr lang="en-US" smtClean="0"/>
               <a:pPr/>
-              <a:t>3/3/2026</a:t>
+              <a:t>3/7/26</a:t>
             </a:fld>
             <a:endParaRPr lang="en-US"/>
           </a:p>
@@ -2808,7 +2808,7 @@
             <a:fld id="{1D8BD707-D9CF-40AE-B4C6-C98DA3205C09}" type="datetimeFigureOut">
               <a:rPr lang="en-US" smtClean="0"/>
               <a:pPr/>
-              <a:t>3/3/2026</a:t>
+              <a:t>3/7/26</a:t>
             </a:fld>
             <a:endParaRPr lang="en-US"/>
           </a:p>
@@ -3101,7 +3101,7 @@
             <a:fld id="{1D8BD707-D9CF-40AE-B4C6-C98DA3205C09}" type="datetimeFigureOut">
               <a:rPr lang="en-US" smtClean="0"/>
               <a:pPr/>
-              <a:t>3/3/2026</a:t>
+              <a:t>3/7/26</a:t>
             </a:fld>
             <a:endParaRPr lang="en-US"/>
           </a:p>
@@ -3559,7 +3559,7 @@
             <a:fld id="{1D8BD707-D9CF-40AE-B4C6-C98DA3205C09}" type="datetimeFigureOut">
               <a:rPr lang="en-US" smtClean="0"/>
               <a:pPr/>
-              <a:t>3/3/2026</a:t>
+              <a:t>3/7/26</a:t>
             </a:fld>
             <a:endParaRPr lang="en-US"/>
           </a:p>
@@ -3719,7 +3719,7 @@
             <a:fld id="{1D8BD707-D9CF-40AE-B4C6-C98DA3205C09}" type="datetimeFigureOut">
               <a:rPr lang="en-US" smtClean="0"/>
               <a:pPr/>
-              <a:t>3/3/2026</a:t>
+              <a:t>3/7/26</a:t>
             </a:fld>
             <a:endParaRPr lang="en-US"/>
           </a:p>
@@ -3846,7 +3846,7 @@
             <a:fld id="{1D8BD707-D9CF-40AE-B4C6-C98DA3205C09}" type="datetimeFigureOut">
               <a:rPr lang="en-US" smtClean="0"/>
               <a:pPr/>
-              <a:t>3/3/2026</a:t>
+              <a:t>3/7/26</a:t>
             </a:fld>
             <a:endParaRPr lang="en-US"/>
           </a:p>
@@ -4118,7 +4118,7 @@
             <a:fld id="{1D8BD707-D9CF-40AE-B4C6-C98DA3205C09}" type="datetimeFigureOut">
               <a:rPr lang="en-US" smtClean="0"/>
               <a:pPr/>
-              <a:t>3/3/2026</a:t>
+              <a:t>3/7/26</a:t>
             </a:fld>
             <a:endParaRPr lang="en-US"/>
           </a:p>
@@ -4367,7 +4367,7 @@
             <a:fld id="{1D8BD707-D9CF-40AE-B4C6-C98DA3205C09}" type="datetimeFigureOut">
               <a:rPr lang="en-US" smtClean="0"/>
               <a:pPr/>
-              <a:t>3/3/2026</a:t>
+              <a:t>3/7/26</a:t>
             </a:fld>
             <a:endParaRPr lang="en-US"/>
           </a:p>
@@ -4575,7 +4575,7 @@
             <a:fld id="{1D8BD707-D9CF-40AE-B4C6-C98DA3205C09}" type="datetimeFigureOut">
               <a:rPr lang="en-US" smtClean="0"/>
               <a:pPr/>
-              <a:t>3/3/2026</a:t>
+              <a:t>3/7/26</a:t>
             </a:fld>
             <a:endParaRPr lang="en-US"/>
           </a:p>

</xml_diff>